<commit_message>
Publish June 26 and June 30 progress, trim presentations to the deck
Add the June 26 and June 30 progress decks and the June 30 batch data
generator (sim source only, comments and docstrings stripped for publication).
Reduce every presentation folder to just progress-deck.pptx and tighten the
allowlist to match. Refresh the June 9 and June 19 decks, and update the README
with run instructions for the June 30 dataset generator plus brief notes on
what June 26 and June 30 delivered.
</commit_message>
<xml_diff>
--- a/meetings/19-june/presentation/progress-deck.pptx
+++ b/meetings/19-june/presentation/progress-deck.pptx
@@ -3223,45 +3223,6 @@
                 <a:latin typeface="Calibri"/>
               </a:rPr>
               <a:t>June 23, 2026</a:t>
-            </a:r>
-          </a:p>
-        </p:txBody>
-      </p:sp>
-      <p:sp>
-        <p:nvSpPr>
-          <p:cNvPr id="4" name="TextBox 3"/>
-          <p:cNvSpPr txBox="1"/>
-          <p:nvPr/>
-        </p:nvSpPr>
-        <p:spPr>
-          <a:xfrm>
-            <a:off x="822960" y="6355080"/>
-            <a:ext cx="10515600" cy="365760"/>
-          </a:xfrm>
-          <a:prstGeom prst="rect">
-            <a:avLst/>
-          </a:prstGeom>
-          <a:noFill/>
-        </p:spPr>
-        <p:txBody>
-          <a:bodyPr wrap="square">
-            <a:spAutoFit/>
-          </a:bodyPr>
-          <a:lstStyle/>
-          <a:p>
-            <a:pPr>
-              <a:spcAft>
-                <a:spcPts val="800"/>
-              </a:spcAft>
-            </a:pPr>
-            <a:r>
-              <a:rPr sz="1100" b="0">
-                <a:solidFill>
-                  <a:srgbClr val="B2B2BE"/>
-                </a:solidFill>
-                <a:latin typeface="Calibri"/>
-              </a:rPr>
-              <a:t>Figures and code produced with AI assistance, disclosed per course policy.</a:t>
             </a:r>
           </a:p>
         </p:txBody>

</xml_diff>